<commit_message>
docs: add speaker notes to architecture-defense deck
Adds ~30s presenter notes to slides 2-8 of W2_Architecture_Defense.pptx
(title and closing already had them), so all 9 slides carry a script for
the 5-minute defense.

Related to #73

Assisted-by: Claude Opus 4.8 <noreply@anthropic.com>
Co-Authored-By: Claude Opus 4.8 <noreply@anthropic.com>
</commit_message>
<xml_diff>
--- a/documentation/W2_Architecture_Defense.pptx
+++ b/documentation/W2_Architecture_Defense.pptx
@@ -598,7 +598,7 @@
           <a:p>
             <a:r>
               <a:rPr lang="en-US" dirty="0"/>
-              <a:t/>
+              <a:t>About 30 seconds. The user has not changed - same cardiologist, same 90-second window between rooms. What changed is that the information that matters today is now trapped in a scanned lab PDF and a front-desk intake form. So Week 2 adds two capabilities: the agent can see documents and extract structured facts with a citation on every field, and it routes that work across a small multi-agent graph. The five chips along the bottom are the hard problems the rest of the deck defends, and every capability still traces to the Week 1 user.</a:t>
             </a:r>
             <a:endParaRPr lang="en-US" dirty="0"/>
           </a:p>
@@ -686,7 +686,7 @@
           <a:p>
             <a:r>
               <a:rPr lang="en-US" dirty="0"/>
-              <a:t/>
+              <a:t>About 35 seconds. First decision: expand the existing .NET sidecar instead of standing up a second Python service. Week 1 already built what Week 2 grades across boundaries - auth, correlation IDs, typed contracts, observability - so one service means one trace, not re-plumbing across a language boundary. The spec explicitly allows equivalents: another inspectable orchestration framework, Cohere Rerank or equivalent. Every named Python tool has a .NET counterpart, shown on the right. Narrower is stronger.</a:t>
             </a:r>
             <a:endParaRPr lang="en-US" dirty="0"/>
           </a:p>
@@ -774,7 +774,7 @@
           <a:p>
             <a:r>
               <a:rPr lang="en-US" dirty="0"/>
-              <a:t/>
+              <a:t>About 35 seconds. This is the strongest decision, and it came from reading the fork's actual route table rather than guessing. The OpenEMR fork's FHIR API is read-only for our data types - no POST for Observation, DocumentReference, or Binary. So we split authority: the source document is written through the standard REST API and is authoritative in OpenEMR; the derived facts have no supported write path, so they live in the sidecar, each citing the OpenEMR document. One authority per data type means the same data is never written twice - no duplicates, no silent overwrites. That directly answers the round-trip-without-duplicates requirement.</a:t>
             </a:r>
             <a:endParaRPr lang="en-US" dirty="0"/>
           </a:p>
@@ -862,7 +862,7 @@
           <a:p>
             <a:r>
               <a:rPr lang="en-US" dirty="0"/>
-              <a:t/>
+              <a:t>About 30 seconds. The graph is deliberately small and typed. A supervisor routes to two workers, intake-extractor and evidence-retriever, and a critic gates the answer. The key move: the critic is not new - it is the Week 1 verification layer promoted to a node, so rejecting uncited or unsafe claims is reuse, not new work. Every handoff is a logged event and each worker span is a child of the supervisor span, so the routing is inspectable from the trace, not a black box.</a:t>
             </a:r>
             <a:endParaRPr lang="en-US" dirty="0"/>
           </a:p>
@@ -950,7 +950,7 @@
           <a:p>
             <a:r>
               <a:rPr lang="en-US" dirty="0"/>
-              <a:t/>
+              <a:t>About 35 seconds. This is the trust core, three parts. One: the schema is the gate - raw vision-model output never bypasses validation; if it fails the schema it is rejected and nothing is persisted. That is how we get vision without invention. Two: hybrid RAG - sparse keyword search and dense vector search in Postgres, merged and reranked, so only the top grounded evidence reaches the model. Three: every claim carries a machine-readable citation plus a bounding box, so clicking a fact highlights the exact region on the source page.</a:t>
             </a:r>
             <a:endParaRPr lang="en-US" dirty="0"/>
           </a:p>
@@ -1038,7 +1038,7 @@
           <a:p>
             <a:r>
               <a:rPr lang="en-US" dirty="0"/>
-              <a:t/>
+              <a:t>About 30 seconds. The architecture is redundant and performant by design. Services are stateless, with session and token state externalized, so they scale out across availability zones behind a load balancer with no single point of failure. Document extraction, the heaviest path, is decoupled onto an async worker pool so it never blocks a request and spikes are absorbed rather than dropped. Hot paths are cached. The sprint demos on Railway, but the same container image scales to the AWS target by config, not a rewrite.</a:t>
             </a:r>
             <a:endParaRPr lang="en-US" dirty="0"/>
           </a:p>
@@ -1126,7 +1126,7 @@
           <a:p>
             <a:r>
               <a:rPr lang="en-US" dirty="0"/>
-              <a:t/>
+              <a:t>About 30 seconds. Quality is proven by a gate that can actually block a merge. Fifty synthetic golden cases, five boolean rubrics - boolean, not one-to-ten, because that makes a regression unambiguous - and the build fails if any category drops more than five percent. Grading injects a regression to confirm the gate blocks it, so we build and test the gate first. The mechanical checks - schema, citation, no PHI - are deterministic; only consistency and refusal use an LLM judge.</a:t>
             </a:r>
             <a:endParaRPr lang="en-US" dirty="0"/>
           </a:p>
@@ -2660,7 +2660,7 @@
       </p:sp>
       <p:sp>
         <p:nvSpPr>
-          <p:cNvPr id="23" name="Text 21"/>
+          <p:cNvPr id="24" name="Text 21"/>
           <p:cNvSpPr/>
           <p:nvPr/>
         </p:nvSpPr>
@@ -2699,7 +2699,7 @@
       </p:sp>
       <p:sp>
         <p:nvSpPr>
-          <p:cNvPr id="24" name="Text 22"/>
+          <p:cNvPr id="25" name="Text 22"/>
           <p:cNvSpPr/>
           <p:nvPr/>
         </p:nvSpPr>
@@ -3418,7 +3418,7 @@
       </p:sp>
       <p:sp>
         <p:nvSpPr>
-          <p:cNvPr id="18" name="Text 16"/>
+          <p:cNvPr id="19" name="Text 16"/>
           <p:cNvSpPr/>
           <p:nvPr/>
         </p:nvSpPr>
@@ -3457,7 +3457,7 @@
       </p:sp>
       <p:sp>
         <p:nvSpPr>
-          <p:cNvPr id="19" name="Text 17"/>
+          <p:cNvPr id="20" name="Text 17"/>
           <p:cNvSpPr/>
           <p:nvPr/>
         </p:nvSpPr>
@@ -3975,7 +3975,7 @@
       </p:sp>
       <p:sp>
         <p:nvSpPr>
-          <p:cNvPr id="13" name="Text 11"/>
+          <p:cNvPr id="14" name="Text 11"/>
           <p:cNvSpPr/>
           <p:nvPr/>
         </p:nvSpPr>
@@ -4014,7 +4014,7 @@
       </p:sp>
       <p:sp>
         <p:nvSpPr>
-          <p:cNvPr id="14" name="Text 12"/>
+          <p:cNvPr id="15" name="Text 12"/>
           <p:cNvSpPr/>
           <p:nvPr/>
         </p:nvSpPr>
@@ -4894,7 +4894,7 @@
       </p:sp>
       <p:sp>
         <p:nvSpPr>
-          <p:cNvPr id="24" name="Text 22"/>
+          <p:cNvPr id="25" name="Text 22"/>
           <p:cNvSpPr/>
           <p:nvPr/>
         </p:nvSpPr>
@@ -4933,7 +4933,7 @@
       </p:sp>
       <p:sp>
         <p:nvSpPr>
-          <p:cNvPr id="25" name="Text 23"/>
+          <p:cNvPr id="26" name="Text 23"/>
           <p:cNvSpPr/>
           <p:nvPr/>
         </p:nvSpPr>
@@ -5580,7 +5580,7 @@
       </p:sp>
       <p:sp>
         <p:nvSpPr>
-          <p:cNvPr id="19" name="Text 17"/>
+          <p:cNvPr id="20" name="Text 17"/>
           <p:cNvSpPr/>
           <p:nvPr/>
         </p:nvSpPr>
@@ -5619,7 +5619,7 @@
       </p:sp>
       <p:sp>
         <p:nvSpPr>
-          <p:cNvPr id="20" name="Text 18"/>
+          <p:cNvPr id="21" name="Text 18"/>
           <p:cNvSpPr/>
           <p:nvPr/>
         </p:nvSpPr>
@@ -6711,7 +6711,7 @@
       </p:sp>
       <p:sp>
         <p:nvSpPr>
-          <p:cNvPr id="31" name="Text 29"/>
+          <p:cNvPr id="32" name="Text 29"/>
           <p:cNvSpPr/>
           <p:nvPr/>
         </p:nvSpPr>
@@ -6750,7 +6750,7 @@
       </p:sp>
       <p:sp>
         <p:nvSpPr>
-          <p:cNvPr id="32" name="Text 30"/>
+          <p:cNvPr id="33" name="Text 30"/>
           <p:cNvSpPr/>
           <p:nvPr/>
         </p:nvSpPr>
@@ -7671,7 +7671,7 @@
       </p:sp>
       <p:sp>
         <p:nvSpPr>
-          <p:cNvPr id="26" name="Text 24"/>
+          <p:cNvPr id="27" name="Text 24"/>
           <p:cNvSpPr/>
           <p:nvPr/>
         </p:nvSpPr>
@@ -7710,7 +7710,7 @@
       </p:sp>
       <p:sp>
         <p:nvSpPr>
-          <p:cNvPr id="27" name="Text 25"/>
+          <p:cNvPr id="28" name="Text 25"/>
           <p:cNvSpPr/>
           <p:nvPr/>
         </p:nvSpPr>

</xml_diff>